<commit_message>
docs: correcciones finales menores
</commit_message>
<xml_diff>
--- a/docs/Ciencia_Ciudadana_Ambiental_v3.pptx
+++ b/docs/Ciencia_Ciudadana_Ambiental_v3.pptx
@@ -10071,8 +10071,8 @@
         </p:nvSpPr>
         <p:spPr>
           <a:xfrm>
-            <a:off x="914400" y="1966280"/>
-            <a:ext cx="3332480" cy="2236194"/>
+            <a:off x="914400" y="1966275"/>
+            <a:ext cx="3332400" cy="2325300"/>
           </a:xfrm>
           <a:prstGeom prst="roundRect">
             <a:avLst>
@@ -10167,7 +10167,7 @@
         <p:spPr>
           <a:xfrm>
             <a:off x="1005850" y="3608127"/>
-            <a:ext cx="3149700" cy="732600"/>
+            <a:ext cx="3149700" cy="683400"/>
           </a:xfrm>
           <a:prstGeom prst="rect">
             <a:avLst/>
@@ -10201,7 +10201,7 @@
               <a:buNone/>
             </a:pPr>
             <a:r>
-              <a:rPr b="1" i="0" lang="en-US" sz="1300" u="none" cap="none" strike="noStrike">
+              <a:rPr b="1" i="0" lang="en-US" sz="1200" u="none" cap="none" strike="noStrike">
                 <a:solidFill>
                   <a:srgbClr val="2A1D12"/>
                 </a:solidFill>
@@ -10212,7 +10212,7 @@
               </a:rPr>
               <a:t>PurpleAir (red ciudadana): cientos de sensores en Brasil, Paraguay y Chile — casi nada en Argentina</a:t>
             </a:r>
-            <a:endParaRPr b="0" i="0" sz="1400" u="none" cap="none" strike="noStrike">
+            <a:endParaRPr b="0" i="0" sz="1300" u="none" cap="none" strike="noStrike">
               <a:solidFill>
                 <a:srgbClr val="000000"/>
               </a:solidFill>
@@ -10232,8 +10232,8 @@
         </p:nvSpPr>
         <p:spPr>
           <a:xfrm>
-            <a:off x="4429760" y="1966280"/>
-            <a:ext cx="3332480" cy="2253339"/>
+            <a:off x="4429750" y="1966275"/>
+            <a:ext cx="3332400" cy="2325300"/>
           </a:xfrm>
           <a:prstGeom prst="roundRect">
             <a:avLst>
@@ -10328,7 +10328,7 @@
         <p:spPr>
           <a:xfrm>
             <a:off x="4521200" y="3625248"/>
-            <a:ext cx="3149700" cy="732600"/>
+            <a:ext cx="3149700" cy="480300"/>
           </a:xfrm>
           <a:prstGeom prst="rect">
             <a:avLst/>
@@ -10362,7 +10362,7 @@
               <a:buNone/>
             </a:pPr>
             <a:r>
-              <a:rPr b="1" i="0" lang="en-US" sz="1300" u="none" cap="none" strike="noStrike">
+              <a:rPr b="1" i="0" lang="en-US" sz="1200" u="none" cap="none" strike="noStrike">
                 <a:solidFill>
                   <a:srgbClr val="2A1D12"/>
                 </a:solidFill>
@@ -10373,7 +10373,7 @@
               </a:rPr>
               <a:t>OpenAQ (red oficial agregada): mismo patrón — Chile con estaciones, Argentina casi vacía</a:t>
             </a:r>
-            <a:endParaRPr b="0" i="0" sz="1400" u="none" cap="none" strike="noStrike">
+            <a:endParaRPr b="0" i="0" sz="1300" u="none" cap="none" strike="noStrike">
               <a:solidFill>
                 <a:srgbClr val="000000"/>
               </a:solidFill>
@@ -10393,8 +10393,8 @@
         </p:nvSpPr>
         <p:spPr>
           <a:xfrm>
-            <a:off x="7945120" y="1966280"/>
-            <a:ext cx="3332480" cy="2253339"/>
+            <a:off x="7945125" y="1966275"/>
+            <a:ext cx="3332400" cy="2325300"/>
           </a:xfrm>
           <a:prstGeom prst="roundRect">
             <a:avLst>
@@ -10489,7 +10489,7 @@
         <p:spPr>
           <a:xfrm>
             <a:off x="8036560" y="3625259"/>
-            <a:ext cx="3149700" cy="512400"/>
+            <a:ext cx="3149700" cy="480300"/>
           </a:xfrm>
           <a:prstGeom prst="rect">
             <a:avLst/>
@@ -10523,7 +10523,7 @@
               <a:buNone/>
             </a:pPr>
             <a:r>
-              <a:rPr b="1" i="0" lang="en-US" sz="1300" u="none" cap="none" strike="noStrike">
+              <a:rPr b="1" i="0" lang="en-US" sz="1200" u="none" cap="none" strike="noStrike">
                 <a:solidFill>
                   <a:srgbClr val="2A1D12"/>
                 </a:solidFill>
@@ -10534,7 +10534,7 @@
               </a:rPr>
               <a:t>Alrededor de Saladillo y 25 de Mayo: solo dos puntos en el mapa</a:t>
             </a:r>
-            <a:endParaRPr b="0" i="0" sz="1400" u="none" cap="none" strike="noStrike">
+            <a:endParaRPr b="0" i="0" sz="1200" u="none" cap="none" strike="noStrike">
               <a:solidFill>
                 <a:srgbClr val="000000"/>
               </a:solidFill>
@@ -13370,17 +13370,16 @@
       </p:sp>
       <p:pic>
         <p:nvPicPr>
-          <p:cNvPr id="372" name="Picture 371" descr="mapa_escuelas_v3.png"/>
-          <p:cNvPicPr>
-            <a:picLocks noChangeAspect="1"/>
-          </p:cNvPicPr>
+          <p:cNvPr descr="mapa_escuelas_v3.png" id="369" name="Google Shape;369;p18"/>
+          <p:cNvPicPr preferRelativeResize="0"/>
           <p:nvPr/>
         </p:nvPicPr>
-        <p:blipFill>
-          <a:blip r:embed="rId5"/>
-          <a:stretch>
-            <a:fillRect/>
-          </a:stretch>
+        <p:blipFill rotWithShape="1">
+          <a:blip r:embed="rId4">
+            <a:alphaModFix/>
+          </a:blip>
+          <a:srcRect b="0" l="0" r="0" t="0"/>
+          <a:stretch/>
         </p:blipFill>
         <p:spPr>
           <a:xfrm>
@@ -13390,6 +13389,10 @@
           <a:prstGeom prst="rect">
             <a:avLst/>
           </a:prstGeom>
+          <a:noFill/>
+          <a:ln>
+            <a:noFill/>
+          </a:ln>
         </p:spPr>
       </p:pic>
       <p:sp>
@@ -16358,8 +16361,8 @@
         </p:nvCxnSpPr>
         <p:spPr>
           <a:xfrm>
-            <a:off x="822960" y="5029200"/>
-            <a:ext cx="9784080" cy="0"/>
+            <a:off x="731460" y="4767350"/>
+            <a:ext cx="9784200" cy="0"/>
           </a:xfrm>
           <a:prstGeom prst="straightConnector1">
             <a:avLst/>
@@ -16391,8 +16394,8 @@
         </p:blipFill>
         <p:spPr>
           <a:xfrm>
-            <a:off x="822960" y="5349240"/>
-            <a:ext cx="274320" cy="274320"/>
+            <a:off x="850385" y="5715440"/>
+            <a:ext cx="274321" cy="274321"/>
           </a:xfrm>
           <a:prstGeom prst="rect">
             <a:avLst/>
@@ -16411,8 +16414,8 @@
         </p:nvSpPr>
         <p:spPr>
           <a:xfrm>
-            <a:off x="1207008" y="5330952"/>
-            <a:ext cx="3200400" cy="320040"/>
+            <a:off x="1207008" y="5692556"/>
+            <a:ext cx="3200400" cy="320100"/>
           </a:xfrm>
           <a:prstGeom prst="rect">
             <a:avLst/>
@@ -16484,8 +16487,8 @@
         </p:blipFill>
         <p:spPr>
           <a:xfrm>
-            <a:off x="4480560" y="5349240"/>
-            <a:ext cx="274320" cy="274320"/>
+            <a:off x="4489697" y="5715490"/>
+            <a:ext cx="274321" cy="274321"/>
           </a:xfrm>
           <a:prstGeom prst="rect">
             <a:avLst/>
@@ -16504,8 +16507,8 @@
         </p:nvSpPr>
         <p:spPr>
           <a:xfrm>
-            <a:off x="4864608" y="5330952"/>
-            <a:ext cx="2011680" cy="320040"/>
+            <a:off x="4846308" y="5692577"/>
+            <a:ext cx="2011800" cy="320100"/>
           </a:xfrm>
           <a:prstGeom prst="rect">
             <a:avLst/>
@@ -16577,8 +16580,8 @@
         </p:blipFill>
         <p:spPr>
           <a:xfrm>
-            <a:off x="6858000" y="5349240"/>
-            <a:ext cx="274320" cy="274320"/>
+            <a:off x="6858100" y="5715490"/>
+            <a:ext cx="274321" cy="274321"/>
           </a:xfrm>
           <a:prstGeom prst="rect">
             <a:avLst/>
@@ -16597,8 +16600,8 @@
         </p:nvSpPr>
         <p:spPr>
           <a:xfrm>
-            <a:off x="7242048" y="5330952"/>
-            <a:ext cx="2011680" cy="320040"/>
+            <a:off x="7296998" y="5692602"/>
+            <a:ext cx="2011800" cy="320100"/>
           </a:xfrm>
           <a:prstGeom prst="rect">
             <a:avLst/>
@@ -16663,7 +16666,7 @@
         </p:nvSpPr>
         <p:spPr>
           <a:xfrm>
-            <a:off x="822960" y="5989320"/>
+            <a:off x="548660" y="5012833"/>
             <a:ext cx="4572000" cy="457200"/>
           </a:xfrm>
           <a:prstGeom prst="rect">
@@ -22471,17 +22474,25 @@
           </a:bodyPr>
           <a:lstStyle/>
           <a:p>
-            <a:pPr indent="0" lvl="0" marL="0" rtl="0" algn="l">
-              <a:spcBef>
-                <a:spcPts val="0"/>
-              </a:spcBef>
-              <a:spcAft>
-                <a:spcPts val="0"/>
-              </a:spcAft>
-              <a:buNone/>
-            </a:pPr>
-            <a:r>
-              <a:rPr i="1" lang="en-US" sz="1100" u="sng">
+            <a:pPr indent="0" lvl="0" marL="0" marR="0" rtl="0" algn="l">
+              <a:lnSpc>
+                <a:spcPct val="100000"/>
+              </a:lnSpc>
+              <a:spcBef>
+                <a:spcPts val="0"/>
+              </a:spcBef>
+              <a:spcAft>
+                <a:spcPts val="0"/>
+              </a:spcAft>
+              <a:buClr>
+                <a:srgbClr val="000000"/>
+              </a:buClr>
+              <a:buSzPts val="1100"/>
+              <a:buFont typeface="Arial"/>
+              <a:buNone/>
+            </a:pPr>
+            <a:r>
+              <a:rPr b="0" i="1" lang="en-US" sz="1100" u="sng" cap="none" strike="noStrike">
                 <a:solidFill>
                   <a:schemeClr val="hlink"/>
                 </a:solidFill>
@@ -22493,7 +22504,10 @@
               </a:rPr>
               <a:t>Especificaciones detalladas de los equipos</a:t>
             </a:r>
-            <a:endParaRPr sz="1200">
+            <a:endParaRPr b="0" i="0" sz="1200" u="none" cap="none" strike="noStrike">
+              <a:solidFill>
+                <a:srgbClr val="000000"/>
+              </a:solidFill>
               <a:latin typeface="Calibri"/>
               <a:ea typeface="Calibri"/>
               <a:cs typeface="Calibri"/>

</xml_diff>